<commit_message>
Collect team preferences as typed Canvas submissions
Switch the team-preference assignment from file upload to text entry;
Canvas's bulk Download Submissions exports each text entry as HTML, so
the answers are easy to tally. Rewrite the assignment handout to match
the printed worksheet (ranked choices, solo option with scope, what
you'd bring), add a fixed layout to type into, and fix the hardcoded
weekday, the pitch length, and the rank-three rule.

Replace the leftover "preference slip" wording in the Session 9 deck,
the schedule, and the Session 10 outline.

Co-Authored-By: Claude Opus 5 (1M context) <noreply@anthropic.com>
Claude-Session: https://claude.ai/code/session_013mMX6YvYXascsmJGBox29p
</commit_message>
<xml_diff>
--- a/canvas_material/lectures/powerpoint/Session09-PitchWorkshop.pptx
+++ b/canvas_material/lectures/powerpoint/Session09-PitchWorkshop.pptx
@@ -1133,7 +1133,7 @@
           <a:p>
             <a:r>
               <a:rPr lang="en-US" dirty="0"/>
-              <a:t>Close fast and concretely — logistics first, because an unclear Pitch Day costs everyone. Say the Monday piece clearly: Wednesday ends with a private ranked slip rather than people sorting into groups, the anchor proposals go up Thursday, and teams are announced Monday — so the weekend reading is real work. Stress the random draw: the order is generated and shown Wednesday at the start of class, so there is no back-of-the-room strategy and nobody gets to watch two pitches first. Everyone prepares to go first. Then the order of operations tonight: rehearse first, build slides second — slides built before the words are decided become the words. End on the line at the top: six minutes to make someone want to build it with you.</a:t>
+              <a:t>Close fast and concretely — logistics first, because an unclear Pitch Day costs everyone. Say the Monday piece clearly: Wednesday ends with a private ranked preference, submitted in Canvas, rather than people sorting into groups, the anchor proposals go up Thursday, and teams are announced Monday — so the weekend reading is real work. Stress the random draw: the order is generated and shown Wednesday at the start of class, so there is no back-of-the-room strategy and nobody gets to watch two pitches first. Everyone prepares to go first. Then the order of operations tonight: rehearse first, build slides second — slides built before the words are decided become the words. End on the line at the top: six minutes to make someone want to build it with you.</a:t>
             </a:r>
             <a:endParaRPr lang="en-US" dirty="0"/>
           </a:p>
@@ -8664,7 +8664,7 @@
                 <a:ea typeface="Calibri" pitchFamily="34" charset="-122"/>
                 <a:cs typeface="Calibri" pitchFamily="34" charset="-120"/>
               </a:rPr>
-              <a:t>You leave with a ranked preference slip, not a team — proposals post Thursday</a:t>
+              <a:t>You leave with a ranked preference, submitted in Canvas — not a team. Proposals post Thursday</a:t>
             </a:r>
             <a:endParaRPr lang="en-US" sz="1550" dirty="0"/>
           </a:p>

</xml_diff>